<commit_message>
Edição final da apresentação
</commit_message>
<xml_diff>
--- a/Apresentação.pptx
+++ b/Apresentação.pptx
@@ -462,7 +462,7 @@
               <a:pPr>
                 <a:defRPr/>
               </a:pPr>
-              <a:t>‹nº›</a:t>
+              <a:t>‹#›</a:t>
             </a:fld>
             <a:endParaRPr lang="pt-BR"/>
           </a:p>
@@ -675,7 +675,7 @@
               <a:pPr>
                 <a:defRPr/>
               </a:pPr>
-              <a:t>‹nº›</a:t>
+              <a:t>‹#›</a:t>
             </a:fld>
             <a:endParaRPr lang="pt-BR"/>
           </a:p>
@@ -898,7 +898,7 @@
               <a:pPr>
                 <a:defRPr/>
               </a:pPr>
-              <a:t>‹nº›</a:t>
+              <a:t>‹#›</a:t>
             </a:fld>
             <a:endParaRPr lang="pt-BR"/>
           </a:p>
@@ -1111,7 +1111,7 @@
               <a:pPr>
                 <a:defRPr/>
               </a:pPr>
-              <a:t>‹nº›</a:t>
+              <a:t>‹#›</a:t>
             </a:fld>
             <a:endParaRPr lang="pt-BR"/>
           </a:p>
@@ -1401,7 +1401,7 @@
               <a:pPr>
                 <a:defRPr/>
               </a:pPr>
-              <a:t>‹nº›</a:t>
+              <a:t>‹#›</a:t>
             </a:fld>
             <a:endParaRPr lang="pt-BR"/>
           </a:p>
@@ -1675,7 +1675,7 @@
               <a:pPr>
                 <a:defRPr/>
               </a:pPr>
-              <a:t>‹nº›</a:t>
+              <a:t>‹#›</a:t>
             </a:fld>
             <a:endParaRPr lang="pt-BR"/>
           </a:p>
@@ -2084,7 +2084,7 @@
               <a:pPr>
                 <a:defRPr/>
               </a:pPr>
-              <a:t>‹nº›</a:t>
+              <a:t>‹#›</a:t>
             </a:fld>
             <a:endParaRPr lang="pt-BR"/>
           </a:p>
@@ -2246,7 +2246,7 @@
               <a:pPr>
                 <a:defRPr/>
               </a:pPr>
-              <a:t>‹nº›</a:t>
+              <a:t>‹#›</a:t>
             </a:fld>
             <a:endParaRPr lang="pt-BR"/>
           </a:p>
@@ -2386,7 +2386,7 @@
               <a:pPr>
                 <a:defRPr/>
               </a:pPr>
-              <a:t>‹nº›</a:t>
+              <a:t>‹#›</a:t>
             </a:fld>
             <a:endParaRPr lang="pt-BR"/>
           </a:p>
@@ -2706,7 +2706,7 @@
               <a:pPr>
                 <a:defRPr/>
               </a:pPr>
-              <a:t>‹nº›</a:t>
+              <a:t>‹#›</a:t>
             </a:fld>
             <a:endParaRPr lang="pt-BR"/>
           </a:p>
@@ -3006,7 +3006,7 @@
               <a:pPr>
                 <a:defRPr/>
               </a:pPr>
-              <a:t>‹nº›</a:t>
+              <a:t>‹#›</a:t>
             </a:fld>
             <a:endParaRPr lang="pt-BR"/>
           </a:p>
@@ -3370,7 +3370,7 @@
               <a:pPr>
                 <a:defRPr/>
               </a:pPr>
-              <a:t>‹nº›</a:t>
+              <a:t>‹#›</a:t>
             </a:fld>
             <a:endParaRPr lang="pt-BR"/>
           </a:p>
@@ -4117,8 +4117,8 @@
         </p:nvSpPr>
         <p:spPr bwMode="auto">
           <a:xfrm>
-            <a:off x="2743200" y="2471738"/>
-            <a:ext cx="6705600" cy="1569660"/>
+            <a:off x="2743200" y="1324425"/>
+            <a:ext cx="6705600" cy="3970318"/>
           </a:xfrm>
           <a:prstGeom prst="rect">
             <a:avLst/>
@@ -4256,7 +4256,7 @@
               </a:spcBef>
             </a:pPr>
             <a:r>
-              <a:rPr lang="en-US" altLang="pt-BR" sz="3200" i="1" dirty="0">
+              <a:rPr lang="en-US" altLang="pt-BR" sz="2800" i="1" dirty="0">
                 <a:solidFill>
                   <a:schemeClr val="bg1"/>
                 </a:solidFill>
@@ -4265,141 +4265,616 @@
               <a:t>“</a:t>
             </a:r>
             <a:r>
-              <a:rPr lang="en-US" altLang="pt-BR" sz="3200" i="1" dirty="0" err="1">
+              <a:rPr lang="en-US" sz="2800" i="1" dirty="0">
                 <a:solidFill>
                   <a:schemeClr val="bg1"/>
                 </a:solidFill>
                 <a:latin typeface="Verdana" panose="020B0604030504040204" pitchFamily="34" charset="0"/>
-              </a:rPr>
-              <a:t>Texto</a:t>
-            </a:r>
-            <a:r>
-              <a:rPr lang="en-US" altLang="pt-BR" sz="3200" i="1" dirty="0">
+                <a:ea typeface="Verdana" panose="020B0604030504040204" pitchFamily="34" charset="0"/>
+              </a:rPr>
+              <a:t>A </a:t>
+            </a:r>
+            <a:r>
+              <a:rPr lang="en-US" sz="2800" i="1" dirty="0" err="1">
                 <a:solidFill>
                   <a:schemeClr val="bg1"/>
                 </a:solidFill>
                 <a:latin typeface="Verdana" panose="020B0604030504040204" pitchFamily="34" charset="0"/>
+                <a:ea typeface="Verdana" panose="020B0604030504040204" pitchFamily="34" charset="0"/>
+              </a:rPr>
+              <a:t>tecnologia</a:t>
+            </a:r>
+            <a:r>
+              <a:rPr lang="en-US" sz="2800" i="1" dirty="0">
+                <a:solidFill>
+                  <a:schemeClr val="bg1"/>
+                </a:solidFill>
+                <a:latin typeface="Verdana" panose="020B0604030504040204" pitchFamily="34" charset="0"/>
+                <a:ea typeface="Verdana" panose="020B0604030504040204" pitchFamily="34" charset="0"/>
               </a:rPr>
               <a:t> </a:t>
             </a:r>
             <a:r>
-              <a:rPr lang="en-US" altLang="pt-BR" sz="3200" i="1" dirty="0" err="1">
+              <a:rPr lang="en-US" sz="2800" i="1" dirty="0" err="1">
                 <a:solidFill>
                   <a:schemeClr val="bg1"/>
                 </a:solidFill>
                 <a:latin typeface="Verdana" panose="020B0604030504040204" pitchFamily="34" charset="0"/>
-              </a:rPr>
-              <a:t>ou</a:t>
-            </a:r>
-            <a:r>
-              <a:rPr lang="en-US" altLang="pt-BR" sz="3200" i="1" dirty="0">
+                <a:ea typeface="Verdana" panose="020B0604030504040204" pitchFamily="34" charset="0"/>
+              </a:rPr>
+              <a:t>não</a:t>
+            </a:r>
+            <a:r>
+              <a:rPr lang="en-US" sz="2800" i="1" dirty="0">
                 <a:solidFill>
                   <a:schemeClr val="bg1"/>
                 </a:solidFill>
                 <a:latin typeface="Verdana" panose="020B0604030504040204" pitchFamily="34" charset="0"/>
+                <a:ea typeface="Verdana" panose="020B0604030504040204" pitchFamily="34" charset="0"/>
               </a:rPr>
               <a:t> </a:t>
             </a:r>
             <a:r>
-              <a:rPr lang="en-US" altLang="pt-BR" sz="3200" i="1" dirty="0" err="1">
+              <a:rPr lang="en-US" sz="2800" i="1" dirty="0" err="1">
                 <a:solidFill>
                   <a:schemeClr val="bg1"/>
                 </a:solidFill>
                 <a:latin typeface="Verdana" panose="020B0604030504040204" pitchFamily="34" charset="0"/>
-              </a:rPr>
-              <a:t>citação</a:t>
-            </a:r>
-            <a:r>
-              <a:rPr lang="en-US" altLang="pt-BR" sz="3200" i="1" dirty="0">
+                <a:ea typeface="Verdana" panose="020B0604030504040204" pitchFamily="34" charset="0"/>
+              </a:rPr>
+              <a:t>exclui</a:t>
+            </a:r>
+            <a:r>
+              <a:rPr lang="en-US" sz="2800" i="1" dirty="0">
                 <a:solidFill>
                   <a:schemeClr val="bg1"/>
                 </a:solidFill>
                 <a:latin typeface="Verdana" panose="020B0604030504040204" pitchFamily="34" charset="0"/>
+                <a:ea typeface="Verdana" panose="020B0604030504040204" pitchFamily="34" charset="0"/>
+              </a:rPr>
+              <a:t> </a:t>
+            </a:r>
+            <a:r>
+              <a:rPr lang="en-US" sz="2800" i="1" dirty="0" err="1">
+                <a:solidFill>
+                  <a:schemeClr val="bg1"/>
+                </a:solidFill>
+                <a:latin typeface="Verdana" panose="020B0604030504040204" pitchFamily="34" charset="0"/>
+                <a:ea typeface="Verdana" panose="020B0604030504040204" pitchFamily="34" charset="0"/>
+              </a:rPr>
+              <a:t>por</a:t>
+            </a:r>
+            <a:r>
+              <a:rPr lang="en-US" sz="2800" i="1" dirty="0">
+                <a:solidFill>
+                  <a:schemeClr val="bg1"/>
+                </a:solidFill>
+                <a:latin typeface="Verdana" panose="020B0604030504040204" pitchFamily="34" charset="0"/>
+                <a:ea typeface="Verdana" panose="020B0604030504040204" pitchFamily="34" charset="0"/>
+              </a:rPr>
+              <a:t> </a:t>
+            </a:r>
+            <a:r>
+              <a:rPr lang="en-US" sz="2800" i="1" dirty="0" err="1">
+                <a:solidFill>
+                  <a:schemeClr val="bg1"/>
+                </a:solidFill>
+                <a:latin typeface="Verdana" panose="020B0604030504040204" pitchFamily="34" charset="0"/>
+                <a:ea typeface="Verdana" panose="020B0604030504040204" pitchFamily="34" charset="0"/>
+              </a:rPr>
+              <a:t>si</a:t>
+            </a:r>
+            <a:r>
+              <a:rPr lang="en-US" sz="2800" i="1" dirty="0">
+                <a:solidFill>
+                  <a:schemeClr val="bg1"/>
+                </a:solidFill>
+                <a:latin typeface="Verdana" panose="020B0604030504040204" pitchFamily="34" charset="0"/>
+                <a:ea typeface="Verdana" panose="020B0604030504040204" pitchFamily="34" charset="0"/>
+              </a:rPr>
+              <a:t> </a:t>
+            </a:r>
+            <a:r>
+              <a:rPr lang="en-US" sz="2800" i="1" dirty="0" err="1">
+                <a:solidFill>
+                  <a:schemeClr val="bg1"/>
+                </a:solidFill>
+                <a:latin typeface="Verdana" panose="020B0604030504040204" pitchFamily="34" charset="0"/>
+                <a:ea typeface="Verdana" panose="020B0604030504040204" pitchFamily="34" charset="0"/>
+              </a:rPr>
+              <a:t>só</a:t>
+            </a:r>
+            <a:r>
+              <a:rPr lang="en-US" sz="2800" i="1" dirty="0">
+                <a:solidFill>
+                  <a:schemeClr val="bg1"/>
+                </a:solidFill>
+                <a:latin typeface="Verdana" panose="020B0604030504040204" pitchFamily="34" charset="0"/>
+                <a:ea typeface="Verdana" panose="020B0604030504040204" pitchFamily="34" charset="0"/>
+              </a:rPr>
+              <a:t>. Ela </a:t>
+            </a:r>
+            <a:r>
+              <a:rPr lang="en-US" sz="2800" i="1" dirty="0" err="1">
+                <a:solidFill>
+                  <a:schemeClr val="bg1"/>
+                </a:solidFill>
+                <a:latin typeface="Verdana" panose="020B0604030504040204" pitchFamily="34" charset="0"/>
+                <a:ea typeface="Verdana" panose="020B0604030504040204" pitchFamily="34" charset="0"/>
+              </a:rPr>
+              <a:t>executa</a:t>
+            </a:r>
+            <a:r>
+              <a:rPr lang="en-US" sz="2800" i="1" dirty="0">
+                <a:solidFill>
+                  <a:schemeClr val="bg1"/>
+                </a:solidFill>
+                <a:latin typeface="Verdana" panose="020B0604030504040204" pitchFamily="34" charset="0"/>
+                <a:ea typeface="Verdana" panose="020B0604030504040204" pitchFamily="34" charset="0"/>
+              </a:rPr>
+              <a:t> </a:t>
+            </a:r>
+            <a:r>
+              <a:rPr lang="en-US" sz="2800" i="1" dirty="0" err="1">
+                <a:solidFill>
+                  <a:schemeClr val="bg1"/>
+                </a:solidFill>
+                <a:latin typeface="Verdana" panose="020B0604030504040204" pitchFamily="34" charset="0"/>
+                <a:ea typeface="Verdana" panose="020B0604030504040204" pitchFamily="34" charset="0"/>
+              </a:rPr>
+              <a:t>escolhas</a:t>
+            </a:r>
+            <a:r>
+              <a:rPr lang="en-US" sz="2800" i="1" dirty="0">
+                <a:solidFill>
+                  <a:schemeClr val="bg1"/>
+                </a:solidFill>
+                <a:latin typeface="Verdana" panose="020B0604030504040204" pitchFamily="34" charset="0"/>
+                <a:ea typeface="Verdana" panose="020B0604030504040204" pitchFamily="34" charset="0"/>
+              </a:rPr>
+              <a:t> </a:t>
+            </a:r>
+            <a:r>
+              <a:rPr lang="en-US" sz="2800" i="1" dirty="0" err="1">
+                <a:solidFill>
+                  <a:schemeClr val="bg1"/>
+                </a:solidFill>
+                <a:latin typeface="Verdana" panose="020B0604030504040204" pitchFamily="34" charset="0"/>
+                <a:ea typeface="Verdana" panose="020B0604030504040204" pitchFamily="34" charset="0"/>
+              </a:rPr>
+              <a:t>previamente</a:t>
+            </a:r>
+            <a:r>
+              <a:rPr lang="en-US" sz="2800" i="1" dirty="0">
+                <a:solidFill>
+                  <a:schemeClr val="bg1"/>
+                </a:solidFill>
+                <a:latin typeface="Verdana" panose="020B0604030504040204" pitchFamily="34" charset="0"/>
+                <a:ea typeface="Verdana" panose="020B0604030504040204" pitchFamily="34" charset="0"/>
+              </a:rPr>
+              <a:t> </a:t>
+            </a:r>
+            <a:r>
+              <a:rPr lang="en-US" sz="2800" i="1" dirty="0" err="1">
+                <a:solidFill>
+                  <a:schemeClr val="bg1"/>
+                </a:solidFill>
+                <a:latin typeface="Verdana" panose="020B0604030504040204" pitchFamily="34" charset="0"/>
+                <a:ea typeface="Verdana" panose="020B0604030504040204" pitchFamily="34" charset="0"/>
+              </a:rPr>
+              <a:t>feitas</a:t>
+            </a:r>
+            <a:r>
+              <a:rPr lang="en-US" sz="2800" i="1" dirty="0">
+                <a:solidFill>
+                  <a:schemeClr val="bg1"/>
+                </a:solidFill>
+                <a:latin typeface="Verdana" panose="020B0604030504040204" pitchFamily="34" charset="0"/>
+                <a:ea typeface="Verdana" panose="020B0604030504040204" pitchFamily="34" charset="0"/>
+              </a:rPr>
+              <a:t>. Quando o </a:t>
+            </a:r>
+            <a:r>
+              <a:rPr lang="en-US" sz="2800" i="1" dirty="0" err="1">
+                <a:solidFill>
+                  <a:schemeClr val="bg1"/>
+                </a:solidFill>
+                <a:latin typeface="Verdana" panose="020B0604030504040204" pitchFamily="34" charset="0"/>
+                <a:ea typeface="Verdana" panose="020B0604030504040204" pitchFamily="34" charset="0"/>
+              </a:rPr>
+              <a:t>serviço</a:t>
+            </a:r>
+            <a:r>
+              <a:rPr lang="en-US" sz="2800" i="1" dirty="0">
+                <a:solidFill>
+                  <a:schemeClr val="bg1"/>
+                </a:solidFill>
+                <a:latin typeface="Verdana" panose="020B0604030504040204" pitchFamily="34" charset="0"/>
+                <a:ea typeface="Verdana" panose="020B0604030504040204" pitchFamily="34" charset="0"/>
+              </a:rPr>
+              <a:t> </a:t>
+            </a:r>
+            <a:r>
+              <a:rPr lang="en-US" sz="2800" i="1" dirty="0" err="1">
+                <a:solidFill>
+                  <a:schemeClr val="bg1"/>
+                </a:solidFill>
+                <a:latin typeface="Verdana" panose="020B0604030504040204" pitchFamily="34" charset="0"/>
+                <a:ea typeface="Verdana" panose="020B0604030504040204" pitchFamily="34" charset="0"/>
+              </a:rPr>
+              <a:t>essencial</a:t>
+            </a:r>
+            <a:r>
+              <a:rPr lang="en-US" sz="2800" i="1" dirty="0">
+                <a:solidFill>
+                  <a:schemeClr val="bg1"/>
+                </a:solidFill>
+                <a:latin typeface="Verdana" panose="020B0604030504040204" pitchFamily="34" charset="0"/>
+                <a:ea typeface="Verdana" panose="020B0604030504040204" pitchFamily="34" charset="0"/>
+              </a:rPr>
+              <a:t> </a:t>
+            </a:r>
+            <a:r>
+              <a:rPr lang="en-US" sz="2800" i="1" dirty="0" err="1">
+                <a:solidFill>
+                  <a:schemeClr val="bg1"/>
+                </a:solidFill>
+                <a:latin typeface="Verdana" panose="020B0604030504040204" pitchFamily="34" charset="0"/>
+                <a:ea typeface="Verdana" panose="020B0604030504040204" pitchFamily="34" charset="0"/>
+              </a:rPr>
+              <a:t>passa</a:t>
+            </a:r>
+            <a:r>
+              <a:rPr lang="en-US" sz="2800" i="1" dirty="0">
+                <a:solidFill>
+                  <a:schemeClr val="bg1"/>
+                </a:solidFill>
+                <a:latin typeface="Verdana" panose="020B0604030504040204" pitchFamily="34" charset="0"/>
+                <a:ea typeface="Verdana" panose="020B0604030504040204" pitchFamily="34" charset="0"/>
+              </a:rPr>
+              <a:t> a </a:t>
+            </a:r>
+            <a:r>
+              <a:rPr lang="en-US" sz="2800" i="1" dirty="0" err="1">
+                <a:solidFill>
+                  <a:schemeClr val="bg1"/>
+                </a:solidFill>
+                <a:latin typeface="Verdana" panose="020B0604030504040204" pitchFamily="34" charset="0"/>
+                <a:ea typeface="Verdana" panose="020B0604030504040204" pitchFamily="34" charset="0"/>
+              </a:rPr>
+              <a:t>existir</a:t>
+            </a:r>
+            <a:r>
+              <a:rPr lang="en-US" sz="2800" i="1" dirty="0">
+                <a:solidFill>
+                  <a:schemeClr val="bg1"/>
+                </a:solidFill>
+                <a:latin typeface="Verdana" panose="020B0604030504040204" pitchFamily="34" charset="0"/>
+                <a:ea typeface="Verdana" panose="020B0604030504040204" pitchFamily="34" charset="0"/>
+              </a:rPr>
+              <a:t> </a:t>
+            </a:r>
+            <a:r>
+              <a:rPr lang="en-US" sz="2800" i="1" dirty="0" err="1">
+                <a:solidFill>
+                  <a:schemeClr val="bg1"/>
+                </a:solidFill>
+                <a:latin typeface="Verdana" panose="020B0604030504040204" pitchFamily="34" charset="0"/>
+                <a:ea typeface="Verdana" panose="020B0604030504040204" pitchFamily="34" charset="0"/>
+              </a:rPr>
+              <a:t>apenas</a:t>
+            </a:r>
+            <a:r>
+              <a:rPr lang="en-US" sz="2800" i="1" dirty="0">
+                <a:solidFill>
+                  <a:schemeClr val="bg1"/>
+                </a:solidFill>
+                <a:latin typeface="Verdana" panose="020B0604030504040204" pitchFamily="34" charset="0"/>
+                <a:ea typeface="Verdana" panose="020B0604030504040204" pitchFamily="34" charset="0"/>
+              </a:rPr>
+              <a:t> </a:t>
+            </a:r>
+            <a:r>
+              <a:rPr lang="en-US" sz="2800" i="1" dirty="0" err="1">
+                <a:solidFill>
+                  <a:schemeClr val="bg1"/>
+                </a:solidFill>
+                <a:latin typeface="Verdana" panose="020B0604030504040204" pitchFamily="34" charset="0"/>
+                <a:ea typeface="Verdana" panose="020B0604030504040204" pitchFamily="34" charset="0"/>
+              </a:rPr>
+              <a:t>em</a:t>
+            </a:r>
+            <a:r>
+              <a:rPr lang="en-US" sz="2800" i="1" dirty="0">
+                <a:solidFill>
+                  <a:schemeClr val="bg1"/>
+                </a:solidFill>
+                <a:latin typeface="Verdana" panose="020B0604030504040204" pitchFamily="34" charset="0"/>
+                <a:ea typeface="Verdana" panose="020B0604030504040204" pitchFamily="34" charset="0"/>
+              </a:rPr>
+              <a:t> </a:t>
+            </a:r>
+            <a:r>
+              <a:rPr lang="en-US" sz="2800" i="1" dirty="0" err="1">
+                <a:solidFill>
+                  <a:schemeClr val="bg1"/>
+                </a:solidFill>
+                <a:latin typeface="Verdana" panose="020B0604030504040204" pitchFamily="34" charset="0"/>
+                <a:ea typeface="Verdana" panose="020B0604030504040204" pitchFamily="34" charset="0"/>
+              </a:rPr>
+              <a:t>formato</a:t>
+            </a:r>
+            <a:r>
+              <a:rPr lang="en-US" sz="2800" i="1" dirty="0">
+                <a:solidFill>
+                  <a:schemeClr val="bg1"/>
+                </a:solidFill>
+                <a:latin typeface="Verdana" panose="020B0604030504040204" pitchFamily="34" charset="0"/>
+                <a:ea typeface="Verdana" panose="020B0604030504040204" pitchFamily="34" charset="0"/>
+              </a:rPr>
+              <a:t> digital </a:t>
+            </a:r>
+            <a:r>
+              <a:rPr lang="en-US" sz="2800" i="1" dirty="0" err="1">
+                <a:solidFill>
+                  <a:schemeClr val="bg1"/>
+                </a:solidFill>
+                <a:latin typeface="Verdana" panose="020B0604030504040204" pitchFamily="34" charset="0"/>
+                <a:ea typeface="Verdana" panose="020B0604030504040204" pitchFamily="34" charset="0"/>
+              </a:rPr>
+              <a:t>sem</a:t>
+            </a:r>
+            <a:r>
+              <a:rPr lang="en-US" sz="2800" i="1" dirty="0">
+                <a:solidFill>
+                  <a:schemeClr val="bg1"/>
+                </a:solidFill>
+                <a:latin typeface="Verdana" panose="020B0604030504040204" pitchFamily="34" charset="0"/>
+                <a:ea typeface="Verdana" panose="020B0604030504040204" pitchFamily="34" charset="0"/>
+              </a:rPr>
+              <a:t> </a:t>
+            </a:r>
+            <a:r>
+              <a:rPr lang="en-US" sz="2800" i="1" dirty="0" err="1">
+                <a:solidFill>
+                  <a:schemeClr val="bg1"/>
+                </a:solidFill>
+                <a:latin typeface="Verdana" panose="020B0604030504040204" pitchFamily="34" charset="0"/>
+                <a:ea typeface="Verdana" panose="020B0604030504040204" pitchFamily="34" charset="0"/>
+              </a:rPr>
+              <a:t>que</a:t>
+            </a:r>
+            <a:r>
+              <a:rPr lang="en-US" sz="2800" i="1" dirty="0">
+                <a:solidFill>
+                  <a:schemeClr val="bg1"/>
+                </a:solidFill>
+                <a:latin typeface="Verdana" panose="020B0604030504040204" pitchFamily="34" charset="0"/>
+                <a:ea typeface="Verdana" panose="020B0604030504040204" pitchFamily="34" charset="0"/>
+              </a:rPr>
+              <a:t> se </a:t>
+            </a:r>
+            <a:r>
+              <a:rPr lang="en-US" sz="2800" i="1" dirty="0" err="1">
+                <a:solidFill>
+                  <a:schemeClr val="bg1"/>
+                </a:solidFill>
+                <a:latin typeface="Verdana" panose="020B0604030504040204" pitchFamily="34" charset="0"/>
+                <a:ea typeface="Verdana" panose="020B0604030504040204" pitchFamily="34" charset="0"/>
+              </a:rPr>
+              <a:t>indague</a:t>
+            </a:r>
+            <a:r>
+              <a:rPr lang="en-US" sz="2800" i="1" dirty="0">
+                <a:solidFill>
+                  <a:schemeClr val="bg1"/>
+                </a:solidFill>
+                <a:latin typeface="Verdana" panose="020B0604030504040204" pitchFamily="34" charset="0"/>
+                <a:ea typeface="Verdana" panose="020B0604030504040204" pitchFamily="34" charset="0"/>
+              </a:rPr>
+              <a:t> quem </a:t>
+            </a:r>
+            <a:r>
+              <a:rPr lang="en-US" sz="2800" i="1" dirty="0" err="1">
+                <a:solidFill>
+                  <a:schemeClr val="bg1"/>
+                </a:solidFill>
+                <a:latin typeface="Verdana" panose="020B0604030504040204" pitchFamily="34" charset="0"/>
+                <a:ea typeface="Verdana" panose="020B0604030504040204" pitchFamily="34" charset="0"/>
+              </a:rPr>
+              <a:t>consegue</a:t>
+            </a:r>
+            <a:r>
+              <a:rPr lang="en-US" sz="2800" i="1" dirty="0">
+                <a:solidFill>
+                  <a:schemeClr val="bg1"/>
+                </a:solidFill>
+                <a:latin typeface="Verdana" panose="020B0604030504040204" pitchFamily="34" charset="0"/>
+                <a:ea typeface="Verdana" panose="020B0604030504040204" pitchFamily="34" charset="0"/>
+              </a:rPr>
+              <a:t> </a:t>
+            </a:r>
+            <a:r>
+              <a:rPr lang="en-US" sz="2800" i="1" dirty="0" err="1">
+                <a:solidFill>
+                  <a:schemeClr val="bg1"/>
+                </a:solidFill>
+                <a:latin typeface="Verdana" panose="020B0604030504040204" pitchFamily="34" charset="0"/>
+                <a:ea typeface="Verdana" panose="020B0604030504040204" pitchFamily="34" charset="0"/>
+              </a:rPr>
+              <a:t>alcançá</a:t>
+            </a:r>
+            <a:r>
+              <a:rPr lang="en-US" sz="2800" i="1" dirty="0">
+                <a:solidFill>
+                  <a:schemeClr val="bg1"/>
+                </a:solidFill>
+                <a:latin typeface="Verdana" panose="020B0604030504040204" pitchFamily="34" charset="0"/>
+                <a:ea typeface="Verdana" panose="020B0604030504040204" pitchFamily="34" charset="0"/>
+              </a:rPr>
+              <a:t>-lo, a </a:t>
+            </a:r>
+            <a:r>
+              <a:rPr lang="en-US" sz="2800" i="1" dirty="0" err="1">
+                <a:solidFill>
+                  <a:schemeClr val="bg1"/>
+                </a:solidFill>
+                <a:latin typeface="Verdana" panose="020B0604030504040204" pitchFamily="34" charset="0"/>
+                <a:ea typeface="Verdana" panose="020B0604030504040204" pitchFamily="34" charset="0"/>
+              </a:rPr>
+              <a:t>exclusão</a:t>
+            </a:r>
+            <a:r>
+              <a:rPr lang="en-US" sz="2800" i="1" dirty="0">
+                <a:solidFill>
+                  <a:schemeClr val="bg1"/>
+                </a:solidFill>
+                <a:latin typeface="Verdana" panose="020B0604030504040204" pitchFamily="34" charset="0"/>
+                <a:ea typeface="Verdana" panose="020B0604030504040204" pitchFamily="34" charset="0"/>
+              </a:rPr>
+              <a:t> </a:t>
+            </a:r>
+            <a:r>
+              <a:rPr lang="en-US" sz="2800" i="1" dirty="0" err="1">
+                <a:solidFill>
+                  <a:schemeClr val="bg1"/>
+                </a:solidFill>
+                <a:latin typeface="Verdana" panose="020B0604030504040204" pitchFamily="34" charset="0"/>
+                <a:ea typeface="Verdana" panose="020B0604030504040204" pitchFamily="34" charset="0"/>
+              </a:rPr>
+              <a:t>deixa</a:t>
+            </a:r>
+            <a:r>
+              <a:rPr lang="en-US" sz="2800" i="1" dirty="0">
+                <a:solidFill>
+                  <a:schemeClr val="bg1"/>
+                </a:solidFill>
+                <a:latin typeface="Verdana" panose="020B0604030504040204" pitchFamily="34" charset="0"/>
+                <a:ea typeface="Verdana" panose="020B0604030504040204" pitchFamily="34" charset="0"/>
+              </a:rPr>
+              <a:t> de ser </a:t>
+            </a:r>
+            <a:r>
+              <a:rPr lang="en-US" sz="2800" i="1" dirty="0" err="1">
+                <a:solidFill>
+                  <a:schemeClr val="bg1"/>
+                </a:solidFill>
+                <a:latin typeface="Verdana" panose="020B0604030504040204" pitchFamily="34" charset="0"/>
+                <a:ea typeface="Verdana" panose="020B0604030504040204" pitchFamily="34" charset="0"/>
+              </a:rPr>
+              <a:t>efeito</a:t>
+            </a:r>
+            <a:r>
+              <a:rPr lang="en-US" sz="2800" i="1" dirty="0">
+                <a:solidFill>
+                  <a:schemeClr val="bg1"/>
+                </a:solidFill>
+                <a:latin typeface="Verdana" panose="020B0604030504040204" pitchFamily="34" charset="0"/>
+                <a:ea typeface="Verdana" panose="020B0604030504040204" pitchFamily="34" charset="0"/>
+              </a:rPr>
+              <a:t> </a:t>
+            </a:r>
+            <a:r>
+              <a:rPr lang="en-US" sz="2800" i="1" dirty="0" err="1">
+                <a:solidFill>
+                  <a:schemeClr val="bg1"/>
+                </a:solidFill>
+                <a:latin typeface="Verdana" panose="020B0604030504040204" pitchFamily="34" charset="0"/>
+                <a:ea typeface="Verdana" panose="020B0604030504040204" pitchFamily="34" charset="0"/>
+              </a:rPr>
+              <a:t>colateral</a:t>
+            </a:r>
+            <a:r>
+              <a:rPr lang="en-US" sz="2800" i="1" dirty="0">
+                <a:solidFill>
+                  <a:schemeClr val="bg1"/>
+                </a:solidFill>
+                <a:latin typeface="Verdana" panose="020B0604030504040204" pitchFamily="34" charset="0"/>
+                <a:ea typeface="Verdana" panose="020B0604030504040204" pitchFamily="34" charset="0"/>
+              </a:rPr>
+              <a:t> e </a:t>
+            </a:r>
+            <a:r>
+              <a:rPr lang="en-US" sz="2800" i="1" dirty="0" err="1">
+                <a:solidFill>
+                  <a:schemeClr val="bg1"/>
+                </a:solidFill>
+                <a:latin typeface="Verdana" panose="020B0604030504040204" pitchFamily="34" charset="0"/>
+                <a:ea typeface="Verdana" panose="020B0604030504040204" pitchFamily="34" charset="0"/>
+              </a:rPr>
+              <a:t>passa</a:t>
+            </a:r>
+            <a:r>
+              <a:rPr lang="en-US" sz="2800" i="1" dirty="0">
+                <a:solidFill>
+                  <a:schemeClr val="bg1"/>
+                </a:solidFill>
+                <a:latin typeface="Verdana" panose="020B0604030504040204" pitchFamily="34" charset="0"/>
+                <a:ea typeface="Verdana" panose="020B0604030504040204" pitchFamily="34" charset="0"/>
+              </a:rPr>
+              <a:t> a ser </a:t>
+            </a:r>
+            <a:r>
+              <a:rPr lang="en-US" sz="2800" i="1" dirty="0" err="1">
+                <a:solidFill>
+                  <a:schemeClr val="bg1"/>
+                </a:solidFill>
+                <a:latin typeface="Verdana" panose="020B0604030504040204" pitchFamily="34" charset="0"/>
+                <a:ea typeface="Verdana" panose="020B0604030504040204" pitchFamily="34" charset="0"/>
+              </a:rPr>
+              <a:t>decisão</a:t>
+            </a:r>
+            <a:r>
+              <a:rPr lang="en-US" sz="2800" i="1" dirty="0">
+                <a:solidFill>
+                  <a:schemeClr val="bg1"/>
+                </a:solidFill>
+                <a:latin typeface="Verdana" panose="020B0604030504040204" pitchFamily="34" charset="0"/>
+                <a:ea typeface="Verdana" panose="020B0604030504040204" pitchFamily="34" charset="0"/>
               </a:rPr>
               <a:t> de </a:t>
             </a:r>
             <a:r>
-              <a:rPr lang="en-US" altLang="pt-BR" sz="3200" i="1" dirty="0" err="1">
+              <a:rPr lang="en-US" sz="2800" i="1" dirty="0" err="1">
                 <a:solidFill>
                   <a:schemeClr val="bg1"/>
                 </a:solidFill>
                 <a:latin typeface="Verdana" panose="020B0604030504040204" pitchFamily="34" charset="0"/>
-              </a:rPr>
-              <a:t>agradecimentos</a:t>
-            </a:r>
-            <a:endParaRPr lang="en-US" altLang="pt-BR" sz="3200" i="1" dirty="0">
-              <a:solidFill>
-                <a:schemeClr val="bg1"/>
-              </a:solidFill>
-              <a:latin typeface="Verdana" panose="020B0604030504040204" pitchFamily="34" charset="0"/>
-            </a:endParaRPr>
-          </a:p>
-          <a:p>
-            <a:pPr algn="ctr" eaLnBrk="1" hangingPunct="1"/>
-            <a:r>
-              <a:rPr lang="en-US" altLang="pt-BR" sz="3200" i="1" dirty="0">
+                <a:ea typeface="Verdana" panose="020B0604030504040204" pitchFamily="34" charset="0"/>
+              </a:rPr>
+              <a:t>projeto</a:t>
+            </a:r>
+            <a:r>
+              <a:rPr lang="en-US" sz="2800" i="1" dirty="0">
                 <a:solidFill>
                   <a:schemeClr val="bg1"/>
                 </a:solidFill>
                 <a:latin typeface="Verdana" panose="020B0604030504040204" pitchFamily="34" charset="0"/>
-              </a:rPr>
-              <a:t>   </a:t>
-            </a:r>
-            <a:r>
-              <a:rPr lang="en-US" altLang="pt-BR" sz="3200" i="1" dirty="0" err="1">
+                <a:ea typeface="Verdana" panose="020B0604030504040204" pitchFamily="34" charset="0"/>
+              </a:rPr>
+              <a:t>."</a:t>
+            </a:r>
+            <a:r>
+              <a:rPr lang="en-US" sz="2800" dirty="0">
                 <a:solidFill>
                   <a:schemeClr val="bg1"/>
                 </a:solidFill>
                 <a:latin typeface="Verdana" panose="020B0604030504040204" pitchFamily="34" charset="0"/>
-              </a:rPr>
-              <a:t>ou</a:t>
-            </a:r>
-            <a:r>
-              <a:rPr lang="en-US" altLang="pt-BR" sz="3200" i="1" dirty="0">
+                <a:ea typeface="Verdana" panose="020B0604030504040204" pitchFamily="34" charset="0"/>
+              </a:rPr>
+              <a:t> (MAIA, 2026).</a:t>
+            </a:r>
+            <a:r>
+              <a:rPr lang="en-US" altLang="pt-BR" sz="2800" i="1" dirty="0">
                 <a:solidFill>
                   <a:schemeClr val="bg1"/>
                 </a:solidFill>
                 <a:latin typeface="Verdana" panose="020B0604030504040204" pitchFamily="34" charset="0"/>
-              </a:rPr>
-              <a:t> </a:t>
-            </a:r>
-            <a:r>
-              <a:rPr lang="en-US" altLang="pt-BR" sz="3200" i="1" dirty="0" err="1">
-                <a:solidFill>
-                  <a:schemeClr val="bg1"/>
-                </a:solidFill>
-                <a:latin typeface="Verdana" panose="020B0604030504040204" pitchFamily="34" charset="0"/>
-              </a:rPr>
-              <a:t>informações</a:t>
-            </a:r>
-            <a:r>
-              <a:rPr lang="en-US" altLang="pt-BR" sz="3200" i="1" dirty="0">
-                <a:solidFill>
-                  <a:schemeClr val="bg1"/>
-                </a:solidFill>
-                <a:latin typeface="Verdana" panose="020B0604030504040204" pitchFamily="34" charset="0"/>
-              </a:rPr>
-              <a:t> </a:t>
-            </a:r>
-            <a:r>
-              <a:rPr lang="en-US" altLang="pt-BR" sz="3200" i="1" dirty="0" err="1">
-                <a:solidFill>
-                  <a:schemeClr val="bg1"/>
-                </a:solidFill>
-                <a:latin typeface="Verdana" panose="020B0604030504040204" pitchFamily="34" charset="0"/>
-              </a:rPr>
-              <a:t>importantes</a:t>
-            </a:r>
-            <a:r>
-              <a:rPr lang="en-US" altLang="pt-BR" sz="3200" i="1" dirty="0">
-                <a:solidFill>
-                  <a:schemeClr val="bg1"/>
-                </a:solidFill>
-                <a:latin typeface="Verdana" panose="020B0604030504040204" pitchFamily="34" charset="0"/>
+                <a:ea typeface="Verdana" panose="020B0604030504040204" pitchFamily="34" charset="0"/>
               </a:rPr>
               <a:t>”</a:t>
             </a:r>
-            <a:endParaRPr lang="pt-BR" altLang="pt-BR" sz="3200" dirty="0">
+            <a:endParaRPr lang="pt-BR" altLang="pt-BR" sz="2800" dirty="0">
               <a:solidFill>
                 <a:srgbClr val="002D55"/>
               </a:solidFill>
@@ -5825,33 +6300,42 @@
                 <a:latin typeface="Verdana" pitchFamily="34" charset="0"/>
                 <a:ea typeface="Verdana" pitchFamily="34" charset="0"/>
               </a:rPr>
-              <a:t>A dificuldade de idosos no uso de aplicativos móveis governamentais</a:t>
-            </a:r>
-          </a:p>
-          <a:p>
-            <a:pPr marL="285750" indent="-285750"/>
+              <a:t>PROBLEMÁTICA:</a:t>
+            </a:r>
+          </a:p>
+          <a:p>
+            <a:pPr marL="1028700" lvl="1"/>
             <a:r>
               <a:rPr lang="pt-BR" sz="1400" dirty="0">
                 <a:latin typeface="Verdana" pitchFamily="34" charset="0"/>
                 <a:ea typeface="Verdana" pitchFamily="34" charset="0"/>
               </a:rPr>
-              <a:t>Exclusão digital decorrente da extinção de canais físicos de atendimento</a:t>
-            </a:r>
-          </a:p>
-          <a:p>
-            <a:pPr marL="285750" indent="-285750"/>
+              <a:t>A dificuldade de idosos no uso de aplicativos móveis governamentais</a:t>
+            </a:r>
+          </a:p>
+          <a:p>
+            <a:pPr marL="1028700" lvl="1"/>
             <a:r>
               <a:rPr lang="pt-BR" sz="1400" dirty="0">
                 <a:latin typeface="Verdana" pitchFamily="34" charset="0"/>
                 <a:ea typeface="Verdana" pitchFamily="34" charset="0"/>
               </a:rPr>
+              <a:t>Exclusão digital decorrente da extinção de canais físicos de atendimento</a:t>
+            </a:r>
+          </a:p>
+          <a:p>
+            <a:pPr marL="1028700" lvl="1"/>
+            <a:r>
+              <a:rPr lang="pt-BR" sz="1400" dirty="0">
+                <a:latin typeface="Verdana" pitchFamily="34" charset="0"/>
+                <a:ea typeface="Verdana" pitchFamily="34" charset="0"/>
+              </a:rPr>
               <a:t>Perda de autonomia e dependência de terceiros</a:t>
             </a:r>
           </a:p>
           <a:p>
-            <a:pPr marL="171450" indent="-171450">
-              <a:buFont typeface="Wingdings" pitchFamily="2" charset="2"/>
-              <a:buChar char="ü"/>
+            <a:pPr>
+              <a:buNone/>
             </a:pPr>
             <a:endParaRPr lang="pt-BR" sz="1400" dirty="0">
               <a:latin typeface="Verdana" pitchFamily="34" charset="0"/>
@@ -5865,18 +6349,42 @@
                 <a:latin typeface="Verdana" pitchFamily="34" charset="0"/>
                 <a:ea typeface="Verdana" pitchFamily="34" charset="0"/>
               </a:rPr>
-              <a:t>Necessidade de preservar a autonomia e cidadania da terceira idade</a:t>
-            </a:r>
-          </a:p>
-          <a:p>
-            <a:pPr marL="285750" indent="-285750"/>
+              <a:t>JUSTIFICATIVA:</a:t>
+            </a:r>
+          </a:p>
+          <a:p>
+            <a:pPr marL="1028700" lvl="1"/>
             <a:r>
               <a:rPr lang="pt-BR" sz="1400" dirty="0">
                 <a:latin typeface="Verdana" pitchFamily="34" charset="0"/>
                 <a:ea typeface="Verdana" pitchFamily="34" charset="0"/>
               </a:rPr>
+              <a:t>Necessidade de preservar a autonomia e cidadania da terceira idade</a:t>
+            </a:r>
+          </a:p>
+          <a:p>
+            <a:pPr marL="1028700" lvl="1"/>
+            <a:r>
+              <a:rPr lang="pt-BR" sz="1400" dirty="0">
+                <a:latin typeface="Verdana" pitchFamily="34" charset="0"/>
+                <a:ea typeface="Verdana" pitchFamily="34" charset="0"/>
+              </a:rPr>
               <a:t>Importância de garantir acesso igualitário aos serviços essenciais do Estado</a:t>
             </a:r>
+          </a:p>
+          <a:p>
+            <a:pPr marL="1028700" lvl="1"/>
+            <a:endParaRPr lang="pt-BR" sz="1400" dirty="0">
+              <a:latin typeface="Verdana" pitchFamily="34" charset="0"/>
+              <a:ea typeface="Verdana" pitchFamily="34" charset="0"/>
+            </a:endParaRPr>
+          </a:p>
+          <a:p>
+            <a:pPr marL="1028700" lvl="1"/>
+            <a:endParaRPr lang="pt-BR" sz="1400" dirty="0">
+              <a:latin typeface="Verdana" pitchFamily="34" charset="0"/>
+              <a:ea typeface="Verdana" pitchFamily="34" charset="0"/>
+            </a:endParaRPr>
           </a:p>
           <a:p>
             <a:pPr>
@@ -6431,21 +6939,48 @@
                 <a:latin typeface="Verdana" panose="020B0604030504040204" pitchFamily="34" charset="0"/>
                 <a:ea typeface="Verdana" panose="020B0604030504040204" pitchFamily="34" charset="0"/>
               </a:rPr>
+              <a:t>OBJETIVO GERAL:</a:t>
+            </a:r>
+          </a:p>
+          <a:p>
+            <a:pPr marL="1028700" lvl="1"/>
+            <a:r>
+              <a:rPr lang="pt-BR" sz="1400" dirty="0">
+                <a:latin typeface="Verdana" panose="020B0604030504040204" pitchFamily="34" charset="0"/>
+                <a:ea typeface="Verdana" panose="020B0604030504040204" pitchFamily="34" charset="0"/>
+              </a:rPr>
               <a:t>Identificar as principais barreiras de acessibilidade digital enfrentadas pelos idosos no uso de aplicativos móveis de serviços públicos, visando promover a inclusão digital e preservar sua autonomia.</a:t>
             </a:r>
           </a:p>
           <a:p>
+            <a:pPr marL="1028700" lvl="1"/>
+            <a:endParaRPr lang="pt-BR" sz="1000" dirty="0">
+              <a:latin typeface="Verdana" panose="020B0604030504040204" pitchFamily="34" charset="0"/>
+              <a:ea typeface="Verdana" panose="020B0604030504040204" pitchFamily="34" charset="0"/>
+            </a:endParaRPr>
+          </a:p>
+          <a:p>
             <a:pPr marL="285750" indent="-285750"/>
             <a:r>
               <a:rPr lang="pt-BR" sz="1400" dirty="0">
                 <a:latin typeface="Verdana" panose="020B0604030504040204" pitchFamily="34" charset="0"/>
                 <a:ea typeface="Verdana" panose="020B0604030504040204" pitchFamily="34" charset="0"/>
               </a:rPr>
+              <a:t>OBJETIVOS ESPECÍFICOS:</a:t>
+            </a:r>
+          </a:p>
+          <a:p>
+            <a:pPr marL="1028700" lvl="1"/>
+            <a:r>
+              <a:rPr lang="pt-BR" sz="1400" dirty="0">
+                <a:latin typeface="Verdana" panose="020B0604030504040204" pitchFamily="34" charset="0"/>
+                <a:ea typeface="Verdana" panose="020B0604030504040204" pitchFamily="34" charset="0"/>
+              </a:rPr>
               <a:t>Buscar soluções para a inclusão digital das pessoas de terceira idade.</a:t>
             </a:r>
           </a:p>
           <a:p>
-            <a:pPr marL="285750" indent="-285750"/>
+            <a:pPr marL="1028700" lvl="1"/>
             <a:r>
               <a:rPr lang="pt-BR" sz="1400" dirty="0">
                 <a:latin typeface="Verdana" panose="020B0604030504040204" pitchFamily="34" charset="0"/>
@@ -6453,12 +6988,19 @@
               </a:rPr>
               <a:t>Melhorar a usabilidade do sistema contribuindo com a inclusão.</a:t>
             </a:r>
+          </a:p>
+          <a:p>
+            <a:pPr marL="1028700" lvl="1"/>
+            <a:endParaRPr lang="pt-BR" sz="1400" dirty="0">
+              <a:latin typeface="Verdana" panose="020B0604030504040204" pitchFamily="34" charset="0"/>
+              <a:ea typeface="Verdana" panose="020B0604030504040204" pitchFamily="34" charset="0"/>
+            </a:endParaRPr>
           </a:p>
           <a:p>
             <a:pPr marL="285750" indent="-285750"/>
             <a:endParaRPr lang="pt-BR" sz="1400" dirty="0">
-              <a:latin typeface="Verdana" pitchFamily="34" charset="0"/>
-              <a:ea typeface="Verdana" pitchFamily="34" charset="0"/>
+              <a:latin typeface="Verdana" panose="020B0604030504040204" pitchFamily="34" charset="0"/>
+              <a:ea typeface="Verdana" panose="020B0604030504040204" pitchFamily="34" charset="0"/>
             </a:endParaRPr>
           </a:p>
           <a:p>
@@ -6467,8 +7009,8 @@
               <a:buChar char="ü"/>
             </a:pPr>
             <a:endParaRPr lang="pt-BR" sz="1400" dirty="0">
-              <a:latin typeface="Verdana" pitchFamily="34" charset="0"/>
-              <a:ea typeface="Verdana" pitchFamily="34" charset="0"/>
+              <a:latin typeface="Verdana" panose="020B0604030504040204" pitchFamily="34" charset="0"/>
+              <a:ea typeface="Verdana" panose="020B0604030504040204" pitchFamily="34" charset="0"/>
             </a:endParaRPr>
           </a:p>
           <a:p>
@@ -6476,8 +7018,8 @@
               <a:buNone/>
             </a:pPr>
             <a:endParaRPr lang="pt-BR" sz="1400" dirty="0">
-              <a:latin typeface="Verdana" pitchFamily="34" charset="0"/>
-              <a:ea typeface="Verdana" pitchFamily="34" charset="0"/>
+              <a:latin typeface="Verdana" panose="020B0604030504040204" pitchFamily="34" charset="0"/>
+              <a:ea typeface="Verdana" panose="020B0604030504040204" pitchFamily="34" charset="0"/>
             </a:endParaRPr>
           </a:p>
           <a:p>
@@ -6486,8 +7028,8 @@
             </a:pPr>
             <a:r>
               <a:rPr lang="pt-BR" sz="1400" dirty="0">
-                <a:latin typeface="Verdana" pitchFamily="34" charset="0"/>
-                <a:ea typeface="Verdana" pitchFamily="34" charset="0"/>
+                <a:latin typeface="Verdana" panose="020B0604030504040204" pitchFamily="34" charset="0"/>
+                <a:ea typeface="Verdana" panose="020B0604030504040204" pitchFamily="34" charset="0"/>
               </a:rPr>
               <a:t> </a:t>
             </a:r>
@@ -6498,8 +7040,8 @@
               <a:buChar char="ü"/>
             </a:pPr>
             <a:endParaRPr lang="pt-BR" sz="1400" dirty="0">
-              <a:latin typeface="Verdana" pitchFamily="34" charset="0"/>
-              <a:ea typeface="Verdana" pitchFamily="34" charset="0"/>
+              <a:latin typeface="Verdana" panose="020B0604030504040204" pitchFamily="34" charset="0"/>
+              <a:ea typeface="Verdana" panose="020B0604030504040204" pitchFamily="34" charset="0"/>
             </a:endParaRPr>
           </a:p>
         </p:txBody>
@@ -6899,7 +7441,7 @@
         <p:spPr bwMode="auto">
           <a:xfrm>
             <a:off x="5630067" y="777875"/>
-            <a:ext cx="5283202" cy="1015663"/>
+            <a:ext cx="5661910" cy="1015663"/>
           </a:xfrm>
           <a:prstGeom prst="rect">
             <a:avLst/>
@@ -6929,7 +7471,7 @@
           </a:extLst>
         </p:spPr>
         <p:txBody>
-          <a:bodyPr>
+          <a:bodyPr wrap="square">
             <a:spAutoFit/>
           </a:bodyPr>
           <a:lstStyle>
@@ -7204,21 +7746,267 @@
               <a:buNone/>
             </a:pPr>
             <a:r>
-              <a:rPr lang="pt-BR" sz="1800" dirty="0">
-                <a:effectLst/>
-                <a:latin typeface="Verdana" panose="020B0604030504040204" pitchFamily="34" charset="0"/>
-                <a:ea typeface="Verdana" panose="020B0604030504040204" pitchFamily="34" charset="0"/>
-              </a:rPr>
-              <a:t>É uma abordagem qualitativa, de natureza teórica, sem procedimentos práticos e baseados em referenciais teóricos. </a:t>
-            </a:r>
-          </a:p>
-          <a:p>
-            <a:pPr>
-              <a:buNone/>
-            </a:pPr>
+              <a:rPr lang="en-US" sz="1400" dirty="0">
+                <a:latin typeface="Verdana" panose="020B0604030504040204" pitchFamily="34" charset="0"/>
+                <a:ea typeface="Verdana" panose="020B0604030504040204" pitchFamily="34" charset="0"/>
+              </a:rPr>
+              <a:t>É </a:t>
+            </a:r>
+            <a:r>
+              <a:rPr lang="en-US" sz="1400" dirty="0" err="1">
+                <a:latin typeface="Verdana" panose="020B0604030504040204" pitchFamily="34" charset="0"/>
+                <a:ea typeface="Verdana" panose="020B0604030504040204" pitchFamily="34" charset="0"/>
+              </a:rPr>
+              <a:t>uma</a:t>
+            </a:r>
+            <a:r>
+              <a:rPr lang="en-US" sz="1400" dirty="0">
+                <a:latin typeface="Verdana" panose="020B0604030504040204" pitchFamily="34" charset="0"/>
+                <a:ea typeface="Verdana" panose="020B0604030504040204" pitchFamily="34" charset="0"/>
+              </a:rPr>
+              <a:t> </a:t>
+            </a:r>
+            <a:r>
+              <a:rPr lang="en-US" sz="1400" dirty="0" err="1">
+                <a:latin typeface="Verdana" panose="020B0604030504040204" pitchFamily="34" charset="0"/>
+                <a:ea typeface="Verdana" panose="020B0604030504040204" pitchFamily="34" charset="0"/>
+              </a:rPr>
+              <a:t>abordagem</a:t>
+            </a:r>
+            <a:r>
+              <a:rPr lang="en-US" sz="1400" dirty="0">
+                <a:latin typeface="Verdana" panose="020B0604030504040204" pitchFamily="34" charset="0"/>
+                <a:ea typeface="Verdana" panose="020B0604030504040204" pitchFamily="34" charset="0"/>
+              </a:rPr>
+              <a:t> </a:t>
+            </a:r>
+            <a:r>
+              <a:rPr lang="en-US" sz="1400" dirty="0" err="1">
+                <a:latin typeface="Verdana" panose="020B0604030504040204" pitchFamily="34" charset="0"/>
+                <a:ea typeface="Verdana" panose="020B0604030504040204" pitchFamily="34" charset="0"/>
+              </a:rPr>
+              <a:t>qualitativa</a:t>
+            </a:r>
+            <a:r>
+              <a:rPr lang="en-US" sz="1400" dirty="0">
+                <a:latin typeface="Verdana" panose="020B0604030504040204" pitchFamily="34" charset="0"/>
+                <a:ea typeface="Verdana" panose="020B0604030504040204" pitchFamily="34" charset="0"/>
+              </a:rPr>
+              <a:t>, de </a:t>
+            </a:r>
+            <a:r>
+              <a:rPr lang="en-US" sz="1400" dirty="0" err="1">
+                <a:latin typeface="Verdana" panose="020B0604030504040204" pitchFamily="34" charset="0"/>
+                <a:ea typeface="Verdana" panose="020B0604030504040204" pitchFamily="34" charset="0"/>
+              </a:rPr>
+              <a:t>natureza</a:t>
+            </a:r>
+            <a:r>
+              <a:rPr lang="en-US" sz="1400" dirty="0">
+                <a:latin typeface="Verdana" panose="020B0604030504040204" pitchFamily="34" charset="0"/>
+                <a:ea typeface="Verdana" panose="020B0604030504040204" pitchFamily="34" charset="0"/>
+              </a:rPr>
+              <a:t> </a:t>
+            </a:r>
+            <a:r>
+              <a:rPr lang="en-US" sz="1400" dirty="0" err="1">
+                <a:latin typeface="Verdana" panose="020B0604030504040204" pitchFamily="34" charset="0"/>
+                <a:ea typeface="Verdana" panose="020B0604030504040204" pitchFamily="34" charset="0"/>
+              </a:rPr>
+              <a:t>teórica</a:t>
+            </a:r>
+            <a:r>
+              <a:rPr lang="en-US" sz="1400" dirty="0">
+                <a:latin typeface="Verdana" panose="020B0604030504040204" pitchFamily="34" charset="0"/>
+                <a:ea typeface="Verdana" panose="020B0604030504040204" pitchFamily="34" charset="0"/>
+              </a:rPr>
+              <a:t>, </a:t>
+            </a:r>
+            <a:r>
+              <a:rPr lang="en-US" sz="1400" dirty="0" err="1">
+                <a:latin typeface="Verdana" panose="020B0604030504040204" pitchFamily="34" charset="0"/>
+                <a:ea typeface="Verdana" panose="020B0604030504040204" pitchFamily="34" charset="0"/>
+              </a:rPr>
+              <a:t>sem</a:t>
+            </a:r>
+            <a:r>
+              <a:rPr lang="en-US" sz="1400" dirty="0">
+                <a:latin typeface="Verdana" panose="020B0604030504040204" pitchFamily="34" charset="0"/>
+                <a:ea typeface="Verdana" panose="020B0604030504040204" pitchFamily="34" charset="0"/>
+              </a:rPr>
+              <a:t> </a:t>
+            </a:r>
+            <a:r>
+              <a:rPr lang="en-US" sz="1400" dirty="0" err="1">
+                <a:latin typeface="Verdana" panose="020B0604030504040204" pitchFamily="34" charset="0"/>
+                <a:ea typeface="Verdana" panose="020B0604030504040204" pitchFamily="34" charset="0"/>
+              </a:rPr>
+              <a:t>procedimentos</a:t>
+            </a:r>
+            <a:r>
+              <a:rPr lang="en-US" sz="1400" dirty="0">
+                <a:latin typeface="Verdana" panose="020B0604030504040204" pitchFamily="34" charset="0"/>
+                <a:ea typeface="Verdana" panose="020B0604030504040204" pitchFamily="34" charset="0"/>
+              </a:rPr>
+              <a:t> </a:t>
+            </a:r>
+            <a:r>
+              <a:rPr lang="en-US" sz="1400" dirty="0" err="1">
+                <a:latin typeface="Verdana" panose="020B0604030504040204" pitchFamily="34" charset="0"/>
+                <a:ea typeface="Verdana" panose="020B0604030504040204" pitchFamily="34" charset="0"/>
+              </a:rPr>
+              <a:t>práticos</a:t>
+            </a:r>
+            <a:r>
+              <a:rPr lang="en-US" sz="1400" dirty="0">
+                <a:latin typeface="Verdana" panose="020B0604030504040204" pitchFamily="34" charset="0"/>
+                <a:ea typeface="Verdana" panose="020B0604030504040204" pitchFamily="34" charset="0"/>
+              </a:rPr>
+              <a:t>, </a:t>
+            </a:r>
+            <a:r>
+              <a:rPr lang="en-US" sz="1400" dirty="0" err="1">
+                <a:latin typeface="Verdana" panose="020B0604030504040204" pitchFamily="34" charset="0"/>
+                <a:ea typeface="Verdana" panose="020B0604030504040204" pitchFamily="34" charset="0"/>
+              </a:rPr>
+              <a:t>baseada</a:t>
+            </a:r>
+            <a:r>
+              <a:rPr lang="en-US" sz="1400" dirty="0">
+                <a:latin typeface="Verdana" panose="020B0604030504040204" pitchFamily="34" charset="0"/>
+                <a:ea typeface="Verdana" panose="020B0604030504040204" pitchFamily="34" charset="0"/>
+              </a:rPr>
+              <a:t> </a:t>
+            </a:r>
+            <a:r>
+              <a:rPr lang="en-US" sz="1400" dirty="0" err="1">
+                <a:latin typeface="Verdana" panose="020B0604030504040204" pitchFamily="34" charset="0"/>
+                <a:ea typeface="Verdana" panose="020B0604030504040204" pitchFamily="34" charset="0"/>
+              </a:rPr>
+              <a:t>em</a:t>
+            </a:r>
+            <a:r>
+              <a:rPr lang="en-US" sz="1400" dirty="0">
+                <a:latin typeface="Verdana" panose="020B0604030504040204" pitchFamily="34" charset="0"/>
+                <a:ea typeface="Verdana" panose="020B0604030504040204" pitchFamily="34" charset="0"/>
+              </a:rPr>
+              <a:t> </a:t>
+            </a:r>
+            <a:r>
+              <a:rPr lang="en-US" sz="1400" dirty="0" err="1">
+                <a:latin typeface="Verdana" panose="020B0604030504040204" pitchFamily="34" charset="0"/>
+                <a:ea typeface="Verdana" panose="020B0604030504040204" pitchFamily="34" charset="0"/>
+              </a:rPr>
+              <a:t>referenciais</a:t>
+            </a:r>
+            <a:r>
+              <a:rPr lang="en-US" sz="1400" dirty="0">
+                <a:latin typeface="Verdana" panose="020B0604030504040204" pitchFamily="34" charset="0"/>
+                <a:ea typeface="Verdana" panose="020B0604030504040204" pitchFamily="34" charset="0"/>
+              </a:rPr>
+              <a:t> </a:t>
+            </a:r>
+            <a:r>
+              <a:rPr lang="en-US" sz="1400" dirty="0" err="1">
+                <a:latin typeface="Verdana" panose="020B0604030504040204" pitchFamily="34" charset="0"/>
+                <a:ea typeface="Verdana" panose="020B0604030504040204" pitchFamily="34" charset="0"/>
+              </a:rPr>
+              <a:t>teóricos</a:t>
+            </a:r>
+            <a:r>
+              <a:rPr lang="en-US" sz="1400" dirty="0">
+                <a:latin typeface="Verdana" panose="020B0604030504040204" pitchFamily="34" charset="0"/>
+                <a:ea typeface="Verdana" panose="020B0604030504040204" pitchFamily="34" charset="0"/>
+              </a:rPr>
+              <a:t> </a:t>
+            </a:r>
+            <a:r>
+              <a:rPr lang="en-US" sz="1400" dirty="0" err="1">
+                <a:latin typeface="Verdana" panose="020B0604030504040204" pitchFamily="34" charset="0"/>
+                <a:ea typeface="Verdana" panose="020B0604030504040204" pitchFamily="34" charset="0"/>
+              </a:rPr>
+              <a:t>sobre</a:t>
+            </a:r>
+            <a:r>
+              <a:rPr lang="en-US" sz="1400" dirty="0">
+                <a:latin typeface="Verdana" panose="020B0604030504040204" pitchFamily="34" charset="0"/>
+                <a:ea typeface="Verdana" panose="020B0604030504040204" pitchFamily="34" charset="0"/>
+              </a:rPr>
+              <a:t> a </a:t>
+            </a:r>
+            <a:r>
+              <a:rPr lang="en-US" sz="1400" dirty="0" err="1">
+                <a:latin typeface="Verdana" panose="020B0604030504040204" pitchFamily="34" charset="0"/>
+                <a:ea typeface="Verdana" panose="020B0604030504040204" pitchFamily="34" charset="0"/>
+              </a:rPr>
+              <a:t>acessibilidade</a:t>
+            </a:r>
+            <a:r>
+              <a:rPr lang="en-US" sz="1400" dirty="0">
+                <a:latin typeface="Verdana" panose="020B0604030504040204" pitchFamily="34" charset="0"/>
+                <a:ea typeface="Verdana" panose="020B0604030504040204" pitchFamily="34" charset="0"/>
+              </a:rPr>
+              <a:t> de </a:t>
+            </a:r>
+            <a:r>
+              <a:rPr lang="en-US" sz="1400" dirty="0" err="1">
+                <a:latin typeface="Verdana" panose="020B0604030504040204" pitchFamily="34" charset="0"/>
+                <a:ea typeface="Verdana" panose="020B0604030504040204" pitchFamily="34" charset="0"/>
+              </a:rPr>
+              <a:t>idosos</a:t>
+            </a:r>
+            <a:r>
+              <a:rPr lang="en-US" sz="1400" dirty="0">
+                <a:latin typeface="Verdana" panose="020B0604030504040204" pitchFamily="34" charset="0"/>
+                <a:ea typeface="Verdana" panose="020B0604030504040204" pitchFamily="34" charset="0"/>
+              </a:rPr>
+              <a:t> </a:t>
+            </a:r>
+            <a:r>
+              <a:rPr lang="en-US" sz="1400" dirty="0" err="1">
+                <a:latin typeface="Verdana" panose="020B0604030504040204" pitchFamily="34" charset="0"/>
+                <a:ea typeface="Verdana" panose="020B0604030504040204" pitchFamily="34" charset="0"/>
+              </a:rPr>
+              <a:t>em</a:t>
+            </a:r>
+            <a:r>
+              <a:rPr lang="en-US" sz="1400" dirty="0">
+                <a:latin typeface="Verdana" panose="020B0604030504040204" pitchFamily="34" charset="0"/>
+                <a:ea typeface="Verdana" panose="020B0604030504040204" pitchFamily="34" charset="0"/>
+              </a:rPr>
+              <a:t> </a:t>
+            </a:r>
+            <a:r>
+              <a:rPr lang="en-US" sz="1400" dirty="0" err="1">
+                <a:latin typeface="Verdana" panose="020B0604030504040204" pitchFamily="34" charset="0"/>
+                <a:ea typeface="Verdana" panose="020B0604030504040204" pitchFamily="34" charset="0"/>
+              </a:rPr>
+              <a:t>aplicativos</a:t>
+            </a:r>
+            <a:r>
+              <a:rPr lang="en-US" sz="1400" dirty="0">
+                <a:latin typeface="Verdana" panose="020B0604030504040204" pitchFamily="34" charset="0"/>
+                <a:ea typeface="Verdana" panose="020B0604030504040204" pitchFamily="34" charset="0"/>
+              </a:rPr>
+              <a:t> </a:t>
+            </a:r>
+            <a:r>
+              <a:rPr lang="en-US" sz="1400" dirty="0" err="1">
+                <a:latin typeface="Verdana" panose="020B0604030504040204" pitchFamily="34" charset="0"/>
+                <a:ea typeface="Verdana" panose="020B0604030504040204" pitchFamily="34" charset="0"/>
+              </a:rPr>
+              <a:t>governamentais</a:t>
+            </a:r>
+            <a:r>
+              <a:rPr lang="en-US" sz="1400" dirty="0">
+                <a:latin typeface="Verdana" panose="020B0604030504040204" pitchFamily="34" charset="0"/>
+                <a:ea typeface="Verdana" panose="020B0604030504040204" pitchFamily="34" charset="0"/>
+              </a:rPr>
+              <a:t>.</a:t>
+            </a:r>
             <a:endParaRPr lang="pt-BR" sz="1400" dirty="0">
-              <a:latin typeface="Verdana" pitchFamily="34" charset="0"/>
-              <a:ea typeface="Verdana" pitchFamily="34" charset="0"/>
+              <a:latin typeface="Verdana" panose="020B0604030504040204" pitchFamily="34" charset="0"/>
+              <a:ea typeface="Verdana" panose="020B0604030504040204" pitchFamily="34" charset="0"/>
             </a:endParaRPr>
           </a:p>
           <a:p>
@@ -9908,15 +10696,6 @@
 </file>
 
 <file path=customXml/item1.xml><?xml version="1.0" encoding="utf-8"?>
-<?mso-contentType ?>
-<FormTemplates xmlns="http://schemas.microsoft.com/sharepoint/v3/contenttype/forms">
-  <Display>DocumentLibraryForm</Display>
-  <Edit>DocumentLibraryForm</Edit>
-  <New>DocumentLibraryForm</New>
-</FormTemplates>
-</file>
-
-<file path=customXml/item2.xml><?xml version="1.0" encoding="utf-8"?>
 <ct:contentTypeSchema xmlns:ct="http://schemas.microsoft.com/office/2006/metadata/contentType" xmlns:ma="http://schemas.microsoft.com/office/2006/metadata/properties/metaAttributes" ct:_="" ma:_="" ma:contentTypeName="Documento" ma:contentTypeID="0x0101001DAED1B117F6894D909B25A69A4597D2" ma:contentTypeVersion="11" ma:contentTypeDescription="Crie um novo documento." ma:contentTypeScope="" ma:versionID="fc0e1081098a96f1fc26b259e7bbb1c8">
   <xsd:schema xmlns:xsd="http://www.w3.org/2001/XMLSchema" xmlns:xs="http://www.w3.org/2001/XMLSchema" xmlns:p="http://schemas.microsoft.com/office/2006/metadata/properties" xmlns:ns2="0cd93fe2-0880-41f5-aab4-f958682b72cb" xmlns:ns3="18000554-2c77-4cf4-9366-a485aa9d7e35" targetNamespace="http://schemas.microsoft.com/office/2006/metadata/properties" ma:root="true" ma:fieldsID="f39cd65ee00b5e4c5dd2756fb7575f2f" ns2:_="" ns3:_="">
     <xsd:import namespace="0cd93fe2-0880-41f5-aab4-f958682b72cb"/>
@@ -10127,15 +10906,16 @@
 </ct:contentTypeSchema>
 </file>
 
-<file path=customXml/itemProps1.xml><?xml version="1.0" encoding="utf-8"?>
-<ds:datastoreItem xmlns:ds="http://schemas.openxmlformats.org/officeDocument/2006/customXml" ds:itemID="{A4661556-5590-415F-9315-F9BACBDA7B81}">
-  <ds:schemaRefs>
-    <ds:schemaRef ds:uri="http://schemas.microsoft.com/sharepoint/v3/contenttype/forms"/>
-  </ds:schemaRefs>
-</ds:datastoreItem>
+<file path=customXml/item2.xml><?xml version="1.0" encoding="utf-8"?>
+<?mso-contentType ?>
+<FormTemplates xmlns="http://schemas.microsoft.com/sharepoint/v3/contenttype/forms">
+  <Display>DocumentLibraryForm</Display>
+  <Edit>DocumentLibraryForm</Edit>
+  <New>DocumentLibraryForm</New>
+</FormTemplates>
 </file>
 
-<file path=customXml/itemProps2.xml><?xml version="1.0" encoding="utf-8"?>
+<file path=customXml/itemProps1.xml><?xml version="1.0" encoding="utf-8"?>
 <ds:datastoreItem xmlns:ds="http://schemas.openxmlformats.org/officeDocument/2006/customXml" ds:itemID="{CEB3752F-42B6-452F-9AAE-531B32224585}">
   <ds:schemaRefs>
     <ds:schemaRef ds:uri="http://schemas.microsoft.com/office/2006/metadata/contentType"/>
@@ -10152,4 +10932,12 @@
     <ds:schemaRef ds:uri="http://schemas.microsoft.com/internal/obd"/>
   </ds:schemaRefs>
 </ds:datastoreItem>
+</file>
+
+<file path=customXml/itemProps2.xml><?xml version="1.0" encoding="utf-8"?>
+<ds:datastoreItem xmlns:ds="http://schemas.openxmlformats.org/officeDocument/2006/customXml" ds:itemID="{A4661556-5590-415F-9315-F9BACBDA7B81}">
+  <ds:schemaRefs>
+    <ds:schemaRef ds:uri="http://schemas.microsoft.com/sharepoint/v3/contenttype/forms"/>
+  </ds:schemaRefs>
+</ds:datastoreItem>
 </file>
</xml_diff>